<commit_message>
Fix tables and cover
</commit_message>
<xml_diff>
--- a/Apresentacao/Apresentacao_MPIO.pptx
+++ b/Apresentacao/Apresentacao_MPIO.pptx
@@ -32,9 +32,9 @@
     <p:sldId id="280" r:id="rId23"/>
     <p:sldId id="275" r:id="rId24"/>
     <p:sldId id="276" r:id="rId25"/>
-    <p:sldId id="270" r:id="rId26"/>
-    <p:sldId id="274" r:id="rId27"/>
-    <p:sldId id="288" r:id="rId28"/>
+    <p:sldId id="288" r:id="rId26"/>
+    <p:sldId id="270" r:id="rId27"/>
+    <p:sldId id="274" r:id="rId28"/>
     <p:sldId id="287" r:id="rId29"/>
   </p:sldIdLst>
   <p:sldSz cx="12192000" cy="6858000"/>
@@ -1681,7 +1681,13 @@
   <p:cSld>
     <p:spTree>
       <p:nvGrpSpPr>
-        <p:cNvPr id="1" name=""/>
+        <p:cNvPr id="1" name="">
+          <a:extLst>
+            <a:ext uri="{FF2B5EF4-FFF2-40B4-BE49-F238E27FC236}">
+              <a16:creationId xmlns:a16="http://schemas.microsoft.com/office/drawing/2014/main" id="{9597C3DA-DC25-5321-D481-23F69FE1DA67}"/>
+            </a:ext>
+          </a:extLst>
+        </p:cNvPr>
         <p:cNvGrpSpPr/>
         <p:nvPr/>
       </p:nvGrpSpPr>
@@ -1695,7 +1701,13 @@
       </p:grpSpPr>
       <p:sp>
         <p:nvSpPr>
-          <p:cNvPr id="2" name="Slide Image Placeholder 1"/>
+          <p:cNvPr id="2" name="Slide Image Placeholder 1">
+            <a:extLst>
+              <a:ext uri="{FF2B5EF4-FFF2-40B4-BE49-F238E27FC236}">
+                <a16:creationId xmlns:a16="http://schemas.microsoft.com/office/drawing/2014/main" id="{FE8E66BA-F66A-0406-9392-BFE24C24A4B3}"/>
+              </a:ext>
+            </a:extLst>
+          </p:cNvPr>
           <p:cNvSpPr>
             <a:spLocks noGrp="1" noRot="1" noChangeAspect="1"/>
           </p:cNvSpPr>
@@ -1707,7 +1719,13 @@
       </p:sp>
       <p:sp>
         <p:nvSpPr>
-          <p:cNvPr id="3" name="Notes Placeholder 2"/>
+          <p:cNvPr id="3" name="Notes Placeholder 2">
+            <a:extLst>
+              <a:ext uri="{FF2B5EF4-FFF2-40B4-BE49-F238E27FC236}">
+                <a16:creationId xmlns:a16="http://schemas.microsoft.com/office/drawing/2014/main" id="{CEECF299-EE20-C3ED-34F8-7837BC840547}"/>
+              </a:ext>
+            </a:extLst>
+          </p:cNvPr>
           <p:cNvSpPr>
             <a:spLocks noGrp="1"/>
           </p:cNvSpPr>
@@ -1726,7 +1744,13 @@
       </p:sp>
       <p:sp>
         <p:nvSpPr>
-          <p:cNvPr id="4" name="Slide Number Placeholder 3"/>
+          <p:cNvPr id="4" name="Slide Number Placeholder 3">
+            <a:extLst>
+              <a:ext uri="{FF2B5EF4-FFF2-40B4-BE49-F238E27FC236}">
+                <a16:creationId xmlns:a16="http://schemas.microsoft.com/office/drawing/2014/main" id="{716686E9-0E54-0D2B-8135-B1859A512065}"/>
+              </a:ext>
+            </a:extLst>
+          </p:cNvPr>
           <p:cNvSpPr>
             <a:spLocks noGrp="1"/>
           </p:cNvSpPr>
@@ -1737,6 +1761,11 @@
         <p:spPr/>
       </p:sp>
     </p:spTree>
+    <p:extLst>
+      <p:ext uri="{BB962C8B-B14F-4D97-AF65-F5344CB8AC3E}">
+        <p14:creationId xmlns:p14="http://schemas.microsoft.com/office/powerpoint/2010/main" val="349750284"/>
+      </p:ext>
+    </p:extLst>
   </p:cSld>
   <p:clrMapOvr>
     <a:masterClrMapping/>
@@ -1817,13 +1846,7 @@
   <p:cSld>
     <p:spTree>
       <p:nvGrpSpPr>
-        <p:cNvPr id="1" name="">
-          <a:extLst>
-            <a:ext uri="{FF2B5EF4-FFF2-40B4-BE49-F238E27FC236}">
-              <a16:creationId xmlns:a16="http://schemas.microsoft.com/office/drawing/2014/main" id="{9597C3DA-DC25-5321-D481-23F69FE1DA67}"/>
-            </a:ext>
-          </a:extLst>
-        </p:cNvPr>
+        <p:cNvPr id="1" name=""/>
         <p:cNvGrpSpPr/>
         <p:nvPr/>
       </p:nvGrpSpPr>
@@ -1837,13 +1860,7 @@
       </p:grpSpPr>
       <p:sp>
         <p:nvSpPr>
-          <p:cNvPr id="2" name="Slide Image Placeholder 1">
-            <a:extLst>
-              <a:ext uri="{FF2B5EF4-FFF2-40B4-BE49-F238E27FC236}">
-                <a16:creationId xmlns:a16="http://schemas.microsoft.com/office/drawing/2014/main" id="{FE8E66BA-F66A-0406-9392-BFE24C24A4B3}"/>
-              </a:ext>
-            </a:extLst>
-          </p:cNvPr>
+          <p:cNvPr id="2" name="Slide Image Placeholder 1"/>
           <p:cNvSpPr>
             <a:spLocks noGrp="1" noRot="1" noChangeAspect="1"/>
           </p:cNvSpPr>
@@ -1855,13 +1872,7 @@
       </p:sp>
       <p:sp>
         <p:nvSpPr>
-          <p:cNvPr id="3" name="Notes Placeholder 2">
-            <a:extLst>
-              <a:ext uri="{FF2B5EF4-FFF2-40B4-BE49-F238E27FC236}">
-                <a16:creationId xmlns:a16="http://schemas.microsoft.com/office/drawing/2014/main" id="{CEECF299-EE20-C3ED-34F8-7837BC840547}"/>
-              </a:ext>
-            </a:extLst>
-          </p:cNvPr>
+          <p:cNvPr id="3" name="Notes Placeholder 2"/>
           <p:cNvSpPr>
             <a:spLocks noGrp="1"/>
           </p:cNvSpPr>
@@ -1880,13 +1891,7 @@
       </p:sp>
       <p:sp>
         <p:nvSpPr>
-          <p:cNvPr id="4" name="Slide Number Placeholder 3">
-            <a:extLst>
-              <a:ext uri="{FF2B5EF4-FFF2-40B4-BE49-F238E27FC236}">
-                <a16:creationId xmlns:a16="http://schemas.microsoft.com/office/drawing/2014/main" id="{716686E9-0E54-0D2B-8135-B1859A512065}"/>
-              </a:ext>
-            </a:extLst>
-          </p:cNvPr>
+          <p:cNvPr id="4" name="Slide Number Placeholder 3"/>
           <p:cNvSpPr>
             <a:spLocks noGrp="1"/>
           </p:cNvSpPr>
@@ -1897,11 +1902,6 @@
         <p:spPr/>
       </p:sp>
     </p:spTree>
-    <p:extLst>
-      <p:ext uri="{BB962C8B-B14F-4D97-AF65-F5344CB8AC3E}">
-        <p14:creationId xmlns:p14="http://schemas.microsoft.com/office/powerpoint/2010/main" val="349750284"/>
-      </p:ext>
-    </p:extLst>
   </p:cSld>
   <p:clrMapOvr>
     <a:masterClrMapping/>
@@ -16627,7 +16627,39 @@
                   <a:srgbClr val="00B050"/>
                 </a:solidFill>
               </a:rPr>
-              <a:t> até 380 Gb/s (113×) na AWS e 34 Gb/s (13,7×) no </a:t>
+              <a:t> até </a:t>
+            </a:r>
+            <a:r>
+              <a:rPr lang="pt-BR" sz="1800" b="1" dirty="0">
+                <a:solidFill>
+                  <a:srgbClr val="00B050"/>
+                </a:solidFill>
+              </a:rPr>
+              <a:t>380 Gb/s (113×) </a:t>
+            </a:r>
+            <a:r>
+              <a:rPr lang="pt-BR" sz="1800" dirty="0">
+                <a:solidFill>
+                  <a:srgbClr val="00B050"/>
+                </a:solidFill>
+              </a:rPr>
+              <a:t>na AWS </a:t>
+            </a:r>
+            <a:r>
+              <a:rPr lang="pt-BR" sz="1800" b="1" dirty="0">
+                <a:solidFill>
+                  <a:srgbClr val="00B050"/>
+                </a:solidFill>
+              </a:rPr>
+              <a:t>e 34 Gb/s (13,7×) </a:t>
+            </a:r>
+            <a:r>
+              <a:rPr lang="pt-BR" sz="1800" dirty="0">
+                <a:solidFill>
+                  <a:srgbClr val="00B050"/>
+                </a:solidFill>
+              </a:rPr>
+              <a:t>no </a:t>
             </a:r>
             <a:r>
               <a:rPr lang="pt-BR" sz="1800" dirty="0" err="1">
@@ -16660,7 +16692,47 @@
                   <a:srgbClr val="00B050"/>
                 </a:solidFill>
               </a:rPr>
-              <a:t>Em 32 nós a E/S consome 49,5% do tempo na implementação atual; com escritas independentes em MPI-IO cai para 0,7%, e o tempo total cai 36,7% (2.013 s → 1.274 s)</a:t>
+              <a:t>Em 32 nós a E/S consome </a:t>
+            </a:r>
+            <a:r>
+              <a:rPr lang="pt-BR" sz="1800" b="1" dirty="0">
+                <a:solidFill>
+                  <a:srgbClr val="00B050"/>
+                </a:solidFill>
+              </a:rPr>
+              <a:t>49,5%</a:t>
+            </a:r>
+            <a:r>
+              <a:rPr lang="pt-BR" sz="1800" dirty="0">
+                <a:solidFill>
+                  <a:srgbClr val="00B050"/>
+                </a:solidFill>
+              </a:rPr>
+              <a:t> do tempo na implementação atual; com escritas independentes em MPI-IO cai para </a:t>
+            </a:r>
+            <a:r>
+              <a:rPr lang="pt-BR" sz="1800" b="1" dirty="0">
+                <a:solidFill>
+                  <a:srgbClr val="00B050"/>
+                </a:solidFill>
+              </a:rPr>
+              <a:t>0,7%, </a:t>
+            </a:r>
+            <a:r>
+              <a:rPr lang="pt-BR" sz="1800" dirty="0">
+                <a:solidFill>
+                  <a:srgbClr val="00B050"/>
+                </a:solidFill>
+              </a:rPr>
+              <a:t>e o tempo total cai </a:t>
+            </a:r>
+            <a:r>
+              <a:rPr lang="pt-BR" sz="1800" b="1" dirty="0">
+                <a:solidFill>
+                  <a:srgbClr val="00B050"/>
+                </a:solidFill>
+              </a:rPr>
+              <a:t>36,7% (2.013 s → 1.274 s)</a:t>
             </a:r>
           </a:p>
           <a:p>
@@ -16677,7 +16749,23 @@
                   <a:srgbClr val="00B050"/>
                 </a:solidFill>
               </a:rPr>
-              <a:t>Portabilidade: o mesmo padrão se repete em nuvem dedicada e em supercomputador compartilhado (40,4% de redução em 32 nós no </a:t>
+              <a:t>Portabilidade: o mesmo padrão se repete em nuvem dedicada e em supercomputador compartilhado (</a:t>
+            </a:r>
+            <a:r>
+              <a:rPr lang="pt-BR" sz="1800" b="1" dirty="0">
+                <a:solidFill>
+                  <a:srgbClr val="00B050"/>
+                </a:solidFill>
+              </a:rPr>
+              <a:t>40,4% </a:t>
+            </a:r>
+            <a:r>
+              <a:rPr lang="pt-BR" sz="1800" dirty="0">
+                <a:solidFill>
+                  <a:srgbClr val="00B050"/>
+                </a:solidFill>
+              </a:rPr>
+              <a:t>de redução em 32 nós no </a:t>
             </a:r>
             <a:r>
               <a:rPr lang="pt-BR" sz="1800" dirty="0" err="1">
@@ -16726,7 +16814,39 @@
                   <a:srgbClr val="FFC000"/>
                 </a:solidFill>
               </a:rPr>
-              <a:t> amplia a banda agregada 5,6× em 16 nós e 23,6× em 32 nós</a:t>
+              <a:t> amplia a banda agregada </a:t>
+            </a:r>
+            <a:r>
+              <a:rPr lang="pt-BR" sz="1800" b="1" dirty="0">
+                <a:solidFill>
+                  <a:srgbClr val="FFC000"/>
+                </a:solidFill>
+              </a:rPr>
+              <a:t>5,6× </a:t>
+            </a:r>
+            <a:r>
+              <a:rPr lang="pt-BR" sz="1800" dirty="0">
+                <a:solidFill>
+                  <a:srgbClr val="FFC000"/>
+                </a:solidFill>
+              </a:rPr>
+              <a:t>em 16 nós e </a:t>
+            </a:r>
+            <a:r>
+              <a:rPr lang="pt-BR" sz="1800" b="1" dirty="0">
+                <a:solidFill>
+                  <a:srgbClr val="FFC000"/>
+                </a:solidFill>
+              </a:rPr>
+              <a:t>23,6× </a:t>
+            </a:r>
+            <a:r>
+              <a:rPr lang="pt-BR" sz="1800" dirty="0">
+                <a:solidFill>
+                  <a:srgbClr val="FFC000"/>
+                </a:solidFill>
+              </a:rPr>
+              <a:t>em 32 nós</a:t>
             </a:r>
           </a:p>
           <a:p>
@@ -16743,7 +16863,23 @@
                   <a:srgbClr val="FF0000"/>
                 </a:solidFill>
               </a:rPr>
-              <a:t>Limites assumidos: eficiência de 43,5% em 32 nós (</a:t>
+              <a:t>Limites assumidos: eficiência de </a:t>
+            </a:r>
+            <a:r>
+              <a:rPr lang="pt-BR" sz="1800" b="1" dirty="0">
+                <a:solidFill>
+                  <a:srgbClr val="FF0000"/>
+                </a:solidFill>
+              </a:rPr>
+              <a:t>43,5</a:t>
+            </a:r>
+            <a:r>
+              <a:rPr lang="pt-BR" sz="1800" dirty="0">
+                <a:solidFill>
+                  <a:srgbClr val="FF0000"/>
+                </a:solidFill>
+              </a:rPr>
+              <a:t>% em 32 nós (</a:t>
             </a:r>
             <a:r>
               <a:rPr lang="pt-BR" sz="1800" dirty="0" err="1">
@@ -16778,7 +16914,7 @@
               <a:t>, gargalo de computação) e </a:t>
             </a:r>
             <a:r>
-              <a:rPr lang="pt-BR" sz="1800" dirty="0" err="1">
+              <a:rPr lang="pt-BR" sz="1800" b="1" dirty="0" err="1">
                 <a:solidFill>
                   <a:srgbClr val="FF0000"/>
                 </a:solidFill>
@@ -16786,12 +16922,36 @@
               <a:t>MPI_File_open</a:t>
             </a:r>
             <a:r>
+              <a:rPr lang="pt-BR" sz="1800" b="1" dirty="0">
+                <a:solidFill>
+                  <a:srgbClr val="FF0000"/>
+                </a:solidFill>
+              </a:rPr>
+              <a:t>/close </a:t>
+            </a:r>
+            <a:r>
               <a:rPr lang="pt-BR" sz="1800" dirty="0">
                 <a:solidFill>
                   <a:srgbClr val="FF0000"/>
                 </a:solidFill>
               </a:rPr>
-              <a:t>/close em 11,6% do tempo — custo fixo por execução, não por carga</a:t>
+              <a:t>em </a:t>
+            </a:r>
+            <a:r>
+              <a:rPr lang="pt-BR" sz="1800" b="1" dirty="0">
+                <a:solidFill>
+                  <a:srgbClr val="FF0000"/>
+                </a:solidFill>
+              </a:rPr>
+              <a:t>11,6% </a:t>
+            </a:r>
+            <a:r>
+              <a:rPr lang="pt-BR" sz="1800" dirty="0">
+                <a:solidFill>
+                  <a:srgbClr val="FF0000"/>
+                </a:solidFill>
+              </a:rPr>
+              <a:t>do tempo — custo fixo por execução, não por carga</a:t>
             </a:r>
           </a:p>
           <a:p>
@@ -16816,7 +16976,39 @@
                   <a:srgbClr val="FF0000"/>
                 </a:solidFill>
               </a:rPr>
-              <a:t>: o escritor único inverte a escalabilidade — na AWS a banda percebida cai de 60,5 para 3,4 Gb/s entre 2 e 32 nós, e o melhor tempo total ocorre em 16 nós, não </a:t>
+              <a:t>: o escritor único inverte a escalabilidade — na AWS a banda percebida cai de </a:t>
+            </a:r>
+            <a:r>
+              <a:rPr sz="1800" b="1" dirty="0">
+                <a:solidFill>
+                  <a:srgbClr val="FF0000"/>
+                </a:solidFill>
+              </a:rPr>
+              <a:t>60,5</a:t>
+            </a:r>
+            <a:r>
+              <a:rPr sz="1800" dirty="0">
+                <a:solidFill>
+                  <a:srgbClr val="FF0000"/>
+                </a:solidFill>
+              </a:rPr>
+              <a:t> para </a:t>
+            </a:r>
+            <a:r>
+              <a:rPr sz="1800" b="1" dirty="0">
+                <a:solidFill>
+                  <a:srgbClr val="FF0000"/>
+                </a:solidFill>
+              </a:rPr>
+              <a:t>3,4 Gb/s </a:t>
+            </a:r>
+            <a:r>
+              <a:rPr sz="1800" dirty="0">
+                <a:solidFill>
+                  <a:srgbClr val="FF0000"/>
+                </a:solidFill>
+              </a:rPr>
+              <a:t>entre 2 e 32 nós, e o melhor tempo total ocorre em 16 nós, não </a:t>
             </a:r>
             <a:r>
               <a:rPr sz="1800" dirty="0" err="1">
@@ -16928,9 +17120,142 @@
               <a:buChar char="§"/>
             </a:pPr>
             <a:r>
-              <a:rPr sz="1800"/>
-              <a:t>Reorganizar o padrão dos arquivos diários (13 dos 117 arquivos), agrupando o mês em uma escrita por (estágio, cenário) — elimina a parcela residual de requisições pequenas</a:t>
-            </a:r>
+              <a:rPr sz="1800" dirty="0" err="1"/>
+              <a:t>Reorganizar</a:t>
+            </a:r>
+            <a:r>
+              <a:rPr sz="1800" dirty="0"/>
+              <a:t> o </a:t>
+            </a:r>
+            <a:r>
+              <a:rPr sz="1800" dirty="0" err="1"/>
+              <a:t>padrão</a:t>
+            </a:r>
+            <a:r>
+              <a:rPr sz="1800" dirty="0"/>
+              <a:t> dos </a:t>
+            </a:r>
+            <a:r>
+              <a:rPr sz="1800" dirty="0" err="1"/>
+              <a:t>arquivos</a:t>
+            </a:r>
+            <a:r>
+              <a:rPr sz="1800" dirty="0"/>
+              <a:t> </a:t>
+            </a:r>
+            <a:r>
+              <a:rPr sz="1800" dirty="0" err="1"/>
+              <a:t>diários</a:t>
+            </a:r>
+            <a:r>
+              <a:rPr sz="1800" dirty="0"/>
+              <a:t> (13 dos 117 </a:t>
+            </a:r>
+            <a:r>
+              <a:rPr sz="1800" dirty="0" err="1"/>
+              <a:t>arquivos</a:t>
+            </a:r>
+            <a:r>
+              <a:rPr sz="1800" dirty="0"/>
+              <a:t>), </a:t>
+            </a:r>
+            <a:r>
+              <a:rPr sz="1800" dirty="0" err="1"/>
+              <a:t>agrupando</a:t>
+            </a:r>
+            <a:r>
+              <a:rPr sz="1800" dirty="0"/>
+              <a:t> o </a:t>
+            </a:r>
+            <a:r>
+              <a:rPr sz="1800" dirty="0" err="1"/>
+              <a:t>mês</a:t>
+            </a:r>
+            <a:r>
+              <a:rPr sz="1800" dirty="0"/>
+              <a:t> </a:t>
+            </a:r>
+            <a:r>
+              <a:rPr sz="1800" dirty="0" err="1"/>
+              <a:t>em</a:t>
+            </a:r>
+            <a:r>
+              <a:rPr sz="1800" dirty="0"/>
+              <a:t> </a:t>
+            </a:r>
+            <a:r>
+              <a:rPr sz="1800" dirty="0" err="1"/>
+              <a:t>uma</a:t>
+            </a:r>
+            <a:r>
+              <a:rPr sz="1800" dirty="0"/>
+              <a:t> </a:t>
+            </a:r>
+            <a:r>
+              <a:rPr sz="1800" dirty="0" err="1"/>
+              <a:t>escrita</a:t>
+            </a:r>
+            <a:r>
+              <a:rPr sz="1800" dirty="0"/>
+              <a:t> </a:t>
+            </a:r>
+            <a:r>
+              <a:rPr sz="1800" dirty="0" err="1"/>
+              <a:t>por</a:t>
+            </a:r>
+            <a:r>
+              <a:rPr sz="1800" dirty="0"/>
+              <a:t> (</a:t>
+            </a:r>
+            <a:r>
+              <a:rPr sz="1800" dirty="0" err="1"/>
+              <a:t>estágio</a:t>
+            </a:r>
+            <a:r>
+              <a:rPr sz="1800" dirty="0"/>
+              <a:t>, </a:t>
+            </a:r>
+            <a:r>
+              <a:rPr sz="1800" dirty="0" err="1"/>
+              <a:t>cenário</a:t>
+            </a:r>
+            <a:r>
+              <a:rPr sz="1800" dirty="0"/>
+              <a:t>) — </a:t>
+            </a:r>
+            <a:r>
+              <a:rPr sz="1800" dirty="0" err="1"/>
+              <a:t>elimina</a:t>
+            </a:r>
+            <a:r>
+              <a:rPr sz="1800" dirty="0"/>
+              <a:t> a </a:t>
+            </a:r>
+            <a:r>
+              <a:rPr sz="1800" dirty="0" err="1"/>
+              <a:t>parcela</a:t>
+            </a:r>
+            <a:r>
+              <a:rPr sz="1800" dirty="0"/>
+              <a:t> residual de </a:t>
+            </a:r>
+            <a:r>
+              <a:rPr sz="1800" dirty="0" err="1"/>
+              <a:t>requisições</a:t>
+            </a:r>
+            <a:r>
+              <a:rPr sz="1800" dirty="0"/>
+              <a:t> </a:t>
+            </a:r>
+            <a:r>
+              <a:rPr sz="1800" dirty="0" err="1"/>
+              <a:t>pequenas</a:t>
+            </a:r>
+            <a:r>
+              <a:rPr lang="en-US" sz="1800" dirty="0"/>
+              <a:t>.</a:t>
+            </a:r>
+            <a:endParaRPr sz="1800" dirty="0"/>
           </a:p>
           <a:p>
             <a:pPr marL="342900" indent="-342900">
@@ -16941,9 +17266,90 @@
               <a:buChar char="§"/>
             </a:pPr>
             <a:r>
-              <a:rPr sz="1800"/>
-              <a:t>Bufferização alinhada às stripes do Lustre, para que cada submissão MPI-IO incida sobre exatamente um OST (Liao et al., 2007)</a:t>
-            </a:r>
+              <a:rPr sz="1800" dirty="0" err="1"/>
+              <a:t>Bufferização</a:t>
+            </a:r>
+            <a:r>
+              <a:rPr sz="1800" dirty="0"/>
+              <a:t> </a:t>
+            </a:r>
+            <a:r>
+              <a:rPr sz="1800" dirty="0" err="1"/>
+              <a:t>alinhada</a:t>
+            </a:r>
+            <a:r>
+              <a:rPr sz="1800" dirty="0"/>
+              <a:t> </a:t>
+            </a:r>
+            <a:r>
+              <a:rPr sz="1800" dirty="0" err="1"/>
+              <a:t>às</a:t>
+            </a:r>
+            <a:r>
+              <a:rPr sz="1800" dirty="0"/>
+              <a:t> stripes do </a:t>
+            </a:r>
+            <a:r>
+              <a:rPr sz="1800" dirty="0" err="1"/>
+              <a:t>Lustre</a:t>
+            </a:r>
+            <a:r>
+              <a:rPr sz="1800" dirty="0"/>
+              <a:t>, para </a:t>
+            </a:r>
+            <a:r>
+              <a:rPr sz="1800" dirty="0" err="1"/>
+              <a:t>que</a:t>
+            </a:r>
+            <a:r>
+              <a:rPr sz="1800" dirty="0"/>
+              <a:t> </a:t>
+            </a:r>
+            <a:r>
+              <a:rPr sz="1800" dirty="0" err="1"/>
+              <a:t>cada</a:t>
+            </a:r>
+            <a:r>
+              <a:rPr sz="1800" dirty="0"/>
+              <a:t> </a:t>
+            </a:r>
+            <a:r>
+              <a:rPr sz="1800" dirty="0" err="1"/>
+              <a:t>submissão</a:t>
+            </a:r>
+            <a:r>
+              <a:rPr sz="1800" dirty="0"/>
+              <a:t> MPI-IO </a:t>
+            </a:r>
+            <a:r>
+              <a:rPr sz="1800" dirty="0" err="1"/>
+              <a:t>incida</a:t>
+            </a:r>
+            <a:r>
+              <a:rPr sz="1800" dirty="0"/>
+              <a:t> </a:t>
+            </a:r>
+            <a:r>
+              <a:rPr sz="1800" dirty="0" err="1"/>
+              <a:t>sobre</a:t>
+            </a:r>
+            <a:r>
+              <a:rPr sz="1800" dirty="0"/>
+              <a:t> </a:t>
+            </a:r>
+            <a:r>
+              <a:rPr sz="1800" dirty="0" err="1"/>
+              <a:t>exatamente</a:t>
+            </a:r>
+            <a:r>
+              <a:rPr sz="1800" dirty="0"/>
+              <a:t> um OST (Liao et al., 2007)</a:t>
+            </a:r>
+            <a:r>
+              <a:rPr lang="en-US" sz="1800" dirty="0"/>
+              <a:t>.</a:t>
+            </a:r>
+            <a:endParaRPr sz="1800" dirty="0"/>
           </a:p>
           <a:p>
             <a:pPr marL="342900" indent="-342900">
@@ -16954,9 +17360,54 @@
               <a:buChar char="§"/>
             </a:pPr>
             <a:r>
-              <a:rPr sz="1800"/>
-              <a:t>Sensibilidade aos parâmetros de projeto: stripe_size do Lustre e limiar síncrono/assíncrono (64, 128 e 256 KB)</a:t>
-            </a:r>
+              <a:rPr sz="1800" dirty="0" err="1"/>
+              <a:t>Sensibilidade</a:t>
+            </a:r>
+            <a:r>
+              <a:rPr sz="1800" dirty="0"/>
+              <a:t> </a:t>
+            </a:r>
+            <a:r>
+              <a:rPr sz="1800" dirty="0" err="1"/>
+              <a:t>aos</a:t>
+            </a:r>
+            <a:r>
+              <a:rPr sz="1800" dirty="0"/>
+              <a:t> </a:t>
+            </a:r>
+            <a:r>
+              <a:rPr sz="1800" dirty="0" err="1"/>
+              <a:t>parâmetros</a:t>
+            </a:r>
+            <a:r>
+              <a:rPr sz="1800" dirty="0"/>
+              <a:t> de </a:t>
+            </a:r>
+            <a:r>
+              <a:rPr sz="1800" dirty="0" err="1"/>
+              <a:t>projeto</a:t>
+            </a:r>
+            <a:r>
+              <a:rPr sz="1800" dirty="0"/>
+              <a:t>: </a:t>
+            </a:r>
+            <a:r>
+              <a:rPr sz="1800" dirty="0" err="1"/>
+              <a:t>stripe_size</a:t>
+            </a:r>
+            <a:r>
+              <a:rPr sz="1800" dirty="0"/>
+              <a:t> do </a:t>
+            </a:r>
+            <a:r>
+              <a:rPr sz="1800" dirty="0" err="1"/>
+              <a:t>Lustre</a:t>
+            </a:r>
+            <a:r>
+              <a:rPr lang="en-US" sz="1800" dirty="0"/>
+              <a:t>.</a:t>
+            </a:r>
+            <a:endParaRPr sz="1800" dirty="0"/>
           </a:p>
           <a:p>
             <a:pPr marL="342900" indent="-342900">
@@ -16967,9 +17418,102 @@
               <a:buChar char="§"/>
             </a:pPr>
             <a:r>
-              <a:rPr sz="1800"/>
-              <a:t>Escrita coletiva (two-phase I/O): tentativas preliminares resultaram em deadlock com o bag-of-tasks — exige reconciliar distribuição dinâmica e semântica coletiva</a:t>
-            </a:r>
+              <a:rPr sz="1800" dirty="0" err="1"/>
+              <a:t>Escrita</a:t>
+            </a:r>
+            <a:r>
+              <a:rPr sz="1800" dirty="0"/>
+              <a:t> </a:t>
+            </a:r>
+            <a:r>
+              <a:rPr sz="1800" dirty="0" err="1"/>
+              <a:t>coletiva</a:t>
+            </a:r>
+            <a:r>
+              <a:rPr sz="1800" dirty="0"/>
+              <a:t> (two-phase I/O): </a:t>
+            </a:r>
+            <a:r>
+              <a:rPr sz="1800" dirty="0" err="1"/>
+              <a:t>tentativas</a:t>
+            </a:r>
+            <a:r>
+              <a:rPr sz="1800" dirty="0"/>
+              <a:t> </a:t>
+            </a:r>
+            <a:r>
+              <a:rPr sz="1800" dirty="0" err="1"/>
+              <a:t>preliminares</a:t>
+            </a:r>
+            <a:r>
+              <a:rPr sz="1800" dirty="0"/>
+              <a:t> </a:t>
+            </a:r>
+            <a:r>
+              <a:rPr sz="1800" dirty="0" err="1"/>
+              <a:t>resultaram</a:t>
+            </a:r>
+            <a:r>
+              <a:rPr sz="1800" dirty="0"/>
+              <a:t> </a:t>
+            </a:r>
+            <a:r>
+              <a:rPr sz="1800" dirty="0" err="1"/>
+              <a:t>em</a:t>
+            </a:r>
+            <a:r>
+              <a:rPr sz="1800" dirty="0"/>
+              <a:t> deadlock com o bag-of-tasks — </a:t>
+            </a:r>
+            <a:r>
+              <a:rPr sz="1800" dirty="0" err="1"/>
+              <a:t>exige</a:t>
+            </a:r>
+            <a:r>
+              <a:rPr sz="1800" dirty="0"/>
+              <a:t> </a:t>
+            </a:r>
+            <a:r>
+              <a:rPr sz="1800" dirty="0" err="1"/>
+              <a:t>reconciliar</a:t>
+            </a:r>
+            <a:r>
+              <a:rPr sz="1800" dirty="0"/>
+              <a:t> </a:t>
+            </a:r>
+            <a:r>
+              <a:rPr sz="1800" dirty="0" err="1"/>
+              <a:t>distribuição</a:t>
+            </a:r>
+            <a:r>
+              <a:rPr sz="1800" dirty="0"/>
+              <a:t> </a:t>
+            </a:r>
+            <a:r>
+              <a:rPr sz="1800" dirty="0" err="1"/>
+              <a:t>dinâmica</a:t>
+            </a:r>
+            <a:r>
+              <a:rPr sz="1800" dirty="0"/>
+              <a:t> e </a:t>
+            </a:r>
+            <a:r>
+              <a:rPr sz="1800" dirty="0" err="1"/>
+              <a:t>semântica</a:t>
+            </a:r>
+            <a:r>
+              <a:rPr sz="1800" dirty="0"/>
+              <a:t> </a:t>
+            </a:r>
+            <a:r>
+              <a:rPr sz="1800" dirty="0" err="1"/>
+              <a:t>coletiva</a:t>
+            </a:r>
+            <a:r>
+              <a:rPr lang="en-US" sz="1800" dirty="0"/>
+              <a:t>.</a:t>
+            </a:r>
+            <a:endParaRPr sz="1800" dirty="0"/>
           </a:p>
           <a:p>
             <a:pPr marL="342900" indent="-342900">
@@ -16980,9 +17524,90 @@
               <a:buChar char="§"/>
             </a:pPr>
             <a:r>
-              <a:rPr sz="1800"/>
-              <a:t>Redes de baixa latência (InfiniBand HDR/NDR, AWS EFA) e escalas acima de 32 nós, onde pode surgir saturação de metadados</a:t>
-            </a:r>
+              <a:rPr sz="1800" dirty="0"/>
+              <a:t>Redes de </a:t>
+            </a:r>
+            <a:r>
+              <a:rPr sz="1800" dirty="0" err="1"/>
+              <a:t>baixa</a:t>
+            </a:r>
+            <a:r>
+              <a:rPr sz="1800" dirty="0"/>
+              <a:t> </a:t>
+            </a:r>
+            <a:r>
+              <a:rPr sz="1800" dirty="0" err="1"/>
+              <a:t>latência</a:t>
+            </a:r>
+            <a:r>
+              <a:rPr sz="1800" dirty="0"/>
+              <a:t> (InfiniBand HDR/NDR, AWS EFA) e </a:t>
+            </a:r>
+            <a:r>
+              <a:rPr sz="1800" dirty="0" err="1"/>
+              <a:t>escalas</a:t>
+            </a:r>
+            <a:r>
+              <a:rPr sz="1800" dirty="0"/>
+              <a:t> </a:t>
+            </a:r>
+            <a:r>
+              <a:rPr sz="1800" dirty="0" err="1"/>
+              <a:t>acima</a:t>
+            </a:r>
+            <a:r>
+              <a:rPr sz="1800" dirty="0"/>
+              <a:t> de 32 </a:t>
+            </a:r>
+            <a:r>
+              <a:rPr sz="1800" dirty="0" err="1"/>
+              <a:t>nós</a:t>
+            </a:r>
+            <a:r>
+              <a:rPr sz="1800" dirty="0"/>
+              <a:t>, </a:t>
+            </a:r>
+            <a:r>
+              <a:rPr sz="1800" dirty="0" err="1"/>
+              <a:t>onde</a:t>
+            </a:r>
+            <a:r>
+              <a:rPr sz="1800" dirty="0"/>
+              <a:t> </a:t>
+            </a:r>
+            <a:r>
+              <a:rPr sz="1800" dirty="0" err="1"/>
+              <a:t>pode</a:t>
+            </a:r>
+            <a:r>
+              <a:rPr sz="1800" dirty="0"/>
+              <a:t> </a:t>
+            </a:r>
+            <a:r>
+              <a:rPr sz="1800" dirty="0" err="1"/>
+              <a:t>surgir</a:t>
+            </a:r>
+            <a:r>
+              <a:rPr sz="1800" dirty="0"/>
+              <a:t> </a:t>
+            </a:r>
+            <a:r>
+              <a:rPr sz="1800" dirty="0" err="1"/>
+              <a:t>saturação</a:t>
+            </a:r>
+            <a:r>
+              <a:rPr sz="1800" dirty="0"/>
+              <a:t> de </a:t>
+            </a:r>
+            <a:r>
+              <a:rPr sz="1800" dirty="0" err="1"/>
+              <a:t>metadados</a:t>
+            </a:r>
+            <a:r>
+              <a:rPr lang="en-US" sz="1800" dirty="0"/>
+              <a:t>.</a:t>
+            </a:r>
+            <a:endParaRPr sz="1800" dirty="0"/>
           </a:p>
           <a:p>
             <a:pPr marL="342900" indent="-342900">
@@ -16993,9 +17618,70 @@
               <a:buChar char="§"/>
             </a:pPr>
             <a:r>
-              <a:rPr sz="1800"/>
-              <a:t>Estender a arquitetura à fase de geração de cortes e diagnosticar o gargalo computacional do regime de strong scaling</a:t>
-            </a:r>
+              <a:rPr sz="1800" dirty="0" err="1"/>
+              <a:t>Estender</a:t>
+            </a:r>
+            <a:r>
+              <a:rPr sz="1800" dirty="0"/>
+              <a:t> a </a:t>
+            </a:r>
+            <a:r>
+              <a:rPr sz="1800" dirty="0" err="1"/>
+              <a:t>arquitetura</a:t>
+            </a:r>
+            <a:r>
+              <a:rPr sz="1800" dirty="0"/>
+              <a:t> à </a:t>
+            </a:r>
+            <a:r>
+              <a:rPr sz="1800" dirty="0" err="1"/>
+              <a:t>fase</a:t>
+            </a:r>
+            <a:r>
+              <a:rPr lang="en-US" sz="1800" dirty="0"/>
+              <a:t> de </a:t>
+            </a:r>
+            <a:r>
+              <a:rPr lang="en-US" sz="1800" dirty="0" err="1"/>
+              <a:t>politica</a:t>
+            </a:r>
+            <a:r>
+              <a:rPr lang="en-US" sz="1800" dirty="0"/>
+              <a:t> </a:t>
+            </a:r>
+            <a:r>
+              <a:rPr sz="1800" dirty="0"/>
+              <a:t>e </a:t>
+            </a:r>
+            <a:r>
+              <a:rPr sz="1800" dirty="0" err="1"/>
+              <a:t>diagnosticar</a:t>
+            </a:r>
+            <a:r>
+              <a:rPr sz="1800" dirty="0"/>
+              <a:t> o </a:t>
+            </a:r>
+            <a:r>
+              <a:rPr sz="1800" dirty="0" err="1"/>
+              <a:t>gargalo</a:t>
+            </a:r>
+            <a:r>
+              <a:rPr sz="1800" dirty="0"/>
+              <a:t> </a:t>
+            </a:r>
+            <a:r>
+              <a:rPr sz="1800" dirty="0" err="1"/>
+              <a:t>computacional</a:t>
+            </a:r>
+            <a:r>
+              <a:rPr sz="1800" dirty="0"/>
+              <a:t> do regime de strong scaling</a:t>
+            </a:r>
+            <a:r>
+              <a:rPr lang="en-US" sz="1800" dirty="0"/>
+              <a:t>.</a:t>
+            </a:r>
+            <a:endParaRPr sz="1800" dirty="0"/>
           </a:p>
         </p:txBody>
       </p:sp>
@@ -17030,190 +17716,6 @@
 </file>
 
 <file path=ppt/slides/slide25.xml><?xml version="1.0" encoding="utf-8"?>
-<p:sld xmlns:a="http://schemas.openxmlformats.org/drawingml/2006/main" xmlns:r="http://schemas.openxmlformats.org/officeDocument/2006/relationships" xmlns:p="http://schemas.openxmlformats.org/presentationml/2006/main">
-  <p:cSld>
-    <p:spTree>
-      <p:nvGrpSpPr>
-        <p:cNvPr id="1" name=""/>
-        <p:cNvGrpSpPr/>
-        <p:nvPr/>
-      </p:nvGrpSpPr>
-      <p:grpSpPr>
-        <a:xfrm>
-          <a:off x="0" y="0"/>
-          <a:ext cx="0" cy="0"/>
-          <a:chOff x="0" y="0"/>
-          <a:chExt cx="0" cy="0"/>
-        </a:xfrm>
-      </p:grpSpPr>
-      <p:sp>
-        <p:nvSpPr>
-          <p:cNvPr id="2" name="Title 1"/>
-          <p:cNvSpPr>
-            <a:spLocks noGrp="1"/>
-          </p:cNvSpPr>
-          <p:nvPr>
-            <p:ph type="title"/>
-          </p:nvPr>
-        </p:nvSpPr>
-        <p:spPr/>
-        <p:txBody>
-          <a:bodyPr/>
-          <a:lstStyle/>
-          <a:p>
-            <a:r>
-              <a:t>Tempo de bloqueio dos envios por tamanho — AWS</a:t>
-            </a:r>
-          </a:p>
-        </p:txBody>
-      </p:sp>
-      <p:sp>
-        <p:nvSpPr>
-          <p:cNvPr id="4" name="Text Placeholder 3"/>
-          <p:cNvSpPr>
-            <a:spLocks noGrp="1"/>
-          </p:cNvSpPr>
-          <p:nvPr>
-            <p:ph type="body" sz="quarter" idx="13"/>
-          </p:nvPr>
-        </p:nvSpPr>
-        <p:spPr/>
-        <p:txBody>
-          <a:bodyPr/>
-          <a:lstStyle/>
-          <a:p>
-            <a:r>
-              <a:rPr sz="1400"/>
-              <a:t>Capítulo 4 — Figura 4.5</a:t>
-            </a:r>
-          </a:p>
-        </p:txBody>
-      </p:sp>
-      <p:pic>
-        <p:nvPicPr>
-          <p:cNvPr id="5" name="Picture 4" descr="EnvioPorTamanho_AWS.png"/>
-          <p:cNvPicPr>
-            <a:picLocks noChangeAspect="1"/>
-          </p:cNvPicPr>
-          <p:nvPr/>
-        </p:nvPicPr>
-        <p:blipFill>
-          <a:blip r:embed="rId3"/>
-          <a:stretch>
-            <a:fillRect/>
-          </a:stretch>
-        </p:blipFill>
-        <p:spPr>
-          <a:xfrm>
-            <a:off x="3009616" y="1371601"/>
-            <a:ext cx="6135809" cy="4924424"/>
-          </a:xfrm>
-          <a:prstGeom prst="rect">
-            <a:avLst/>
-          </a:prstGeom>
-        </p:spPr>
-      </p:pic>
-    </p:spTree>
-  </p:cSld>
-  <p:clrMapOvr>
-    <a:masterClrMapping/>
-  </p:clrMapOvr>
-</p:sld>
-</file>
-
-<file path=ppt/slides/slide26.xml><?xml version="1.0" encoding="utf-8"?>
-<p:sld xmlns:a="http://schemas.openxmlformats.org/drawingml/2006/main" xmlns:r="http://schemas.openxmlformats.org/officeDocument/2006/relationships" xmlns:p="http://schemas.openxmlformats.org/presentationml/2006/main">
-  <p:cSld>
-    <p:spTree>
-      <p:nvGrpSpPr>
-        <p:cNvPr id="1" name=""/>
-        <p:cNvGrpSpPr/>
-        <p:nvPr/>
-      </p:nvGrpSpPr>
-      <p:grpSpPr>
-        <a:xfrm>
-          <a:off x="0" y="0"/>
-          <a:ext cx="0" cy="0"/>
-          <a:chOff x="0" y="0"/>
-          <a:chExt cx="0" cy="0"/>
-        </a:xfrm>
-      </p:grpSpPr>
-      <p:sp>
-        <p:nvSpPr>
-          <p:cNvPr id="2" name="Title 1"/>
-          <p:cNvSpPr>
-            <a:spLocks noGrp="1"/>
-          </p:cNvSpPr>
-          <p:nvPr>
-            <p:ph type="title"/>
-          </p:nvPr>
-        </p:nvSpPr>
-        <p:spPr/>
-        <p:txBody>
-          <a:bodyPr/>
-          <a:lstStyle/>
-          <a:p>
-            <a:r>
-              <a:t>Tempo de bloqueio dos envios por tamanho — SDumont</a:t>
-            </a:r>
-          </a:p>
-        </p:txBody>
-      </p:sp>
-      <p:sp>
-        <p:nvSpPr>
-          <p:cNvPr id="4" name="Text Placeholder 3"/>
-          <p:cNvSpPr>
-            <a:spLocks noGrp="1"/>
-          </p:cNvSpPr>
-          <p:nvPr>
-            <p:ph type="body" sz="quarter" idx="13"/>
-          </p:nvPr>
-        </p:nvSpPr>
-        <p:spPr/>
-        <p:txBody>
-          <a:bodyPr/>
-          <a:lstStyle/>
-          <a:p>
-            <a:r>
-              <a:rPr sz="1400"/>
-              <a:t>Capítulo 4 — Figura 4.10</a:t>
-            </a:r>
-          </a:p>
-        </p:txBody>
-      </p:sp>
-      <p:pic>
-        <p:nvPicPr>
-          <p:cNvPr id="5" name="Picture 4" descr="EnvioPorTamanho_SDumont.png"/>
-          <p:cNvPicPr>
-            <a:picLocks noChangeAspect="1"/>
-          </p:cNvPicPr>
-          <p:nvPr/>
-        </p:nvPicPr>
-        <p:blipFill>
-          <a:blip r:embed="rId3"/>
-          <a:stretch>
-            <a:fillRect/>
-          </a:stretch>
-        </p:blipFill>
-        <p:spPr>
-          <a:xfrm>
-            <a:off x="3009616" y="1371601"/>
-            <a:ext cx="6135809" cy="4924424"/>
-          </a:xfrm>
-          <a:prstGeom prst="rect">
-            <a:avLst/>
-          </a:prstGeom>
-        </p:spPr>
-      </p:pic>
-    </p:spTree>
-  </p:cSld>
-  <p:clrMapOvr>
-    <a:masterClrMapping/>
-  </p:clrMapOvr>
-</p:sld>
-</file>
-
-<file path=ppt/slides/slide27.xml><?xml version="1.0" encoding="utf-8"?>
 <p:sld xmlns:a="http://schemas.openxmlformats.org/drawingml/2006/main" xmlns:r="http://schemas.openxmlformats.org/officeDocument/2006/relationships" xmlns:p="http://schemas.openxmlformats.org/presentationml/2006/main">
   <p:cSld>
     <p:spTree>
@@ -17331,6 +17833,190 @@
         <p14:creationId xmlns:p14="http://schemas.microsoft.com/office/powerpoint/2010/main" val="984290397"/>
       </p:ext>
     </p:extLst>
+  </p:cSld>
+  <p:clrMapOvr>
+    <a:masterClrMapping/>
+  </p:clrMapOvr>
+</p:sld>
+</file>
+
+<file path=ppt/slides/slide26.xml><?xml version="1.0" encoding="utf-8"?>
+<p:sld xmlns:a="http://schemas.openxmlformats.org/drawingml/2006/main" xmlns:r="http://schemas.openxmlformats.org/officeDocument/2006/relationships" xmlns:p="http://schemas.openxmlformats.org/presentationml/2006/main">
+  <p:cSld>
+    <p:spTree>
+      <p:nvGrpSpPr>
+        <p:cNvPr id="1" name=""/>
+        <p:cNvGrpSpPr/>
+        <p:nvPr/>
+      </p:nvGrpSpPr>
+      <p:grpSpPr>
+        <a:xfrm>
+          <a:off x="0" y="0"/>
+          <a:ext cx="0" cy="0"/>
+          <a:chOff x="0" y="0"/>
+          <a:chExt cx="0" cy="0"/>
+        </a:xfrm>
+      </p:grpSpPr>
+      <p:sp>
+        <p:nvSpPr>
+          <p:cNvPr id="2" name="Title 1"/>
+          <p:cNvSpPr>
+            <a:spLocks noGrp="1"/>
+          </p:cNvSpPr>
+          <p:nvPr>
+            <p:ph type="title"/>
+          </p:nvPr>
+        </p:nvSpPr>
+        <p:spPr/>
+        <p:txBody>
+          <a:bodyPr/>
+          <a:lstStyle/>
+          <a:p>
+            <a:r>
+              <a:t>Tempo de bloqueio dos envios por tamanho — AWS</a:t>
+            </a:r>
+          </a:p>
+        </p:txBody>
+      </p:sp>
+      <p:sp>
+        <p:nvSpPr>
+          <p:cNvPr id="4" name="Text Placeholder 3"/>
+          <p:cNvSpPr>
+            <a:spLocks noGrp="1"/>
+          </p:cNvSpPr>
+          <p:nvPr>
+            <p:ph type="body" sz="quarter" idx="13"/>
+          </p:nvPr>
+        </p:nvSpPr>
+        <p:spPr/>
+        <p:txBody>
+          <a:bodyPr/>
+          <a:lstStyle/>
+          <a:p>
+            <a:r>
+              <a:rPr sz="1400"/>
+              <a:t>Capítulo 4 — Figura 4.5</a:t>
+            </a:r>
+          </a:p>
+        </p:txBody>
+      </p:sp>
+      <p:pic>
+        <p:nvPicPr>
+          <p:cNvPr id="5" name="Picture 4" descr="EnvioPorTamanho_AWS.png"/>
+          <p:cNvPicPr>
+            <a:picLocks noChangeAspect="1"/>
+          </p:cNvPicPr>
+          <p:nvPr/>
+        </p:nvPicPr>
+        <p:blipFill>
+          <a:blip r:embed="rId3"/>
+          <a:stretch>
+            <a:fillRect/>
+          </a:stretch>
+        </p:blipFill>
+        <p:spPr>
+          <a:xfrm>
+            <a:off x="3009616" y="1371601"/>
+            <a:ext cx="6135809" cy="4924424"/>
+          </a:xfrm>
+          <a:prstGeom prst="rect">
+            <a:avLst/>
+          </a:prstGeom>
+        </p:spPr>
+      </p:pic>
+    </p:spTree>
+  </p:cSld>
+  <p:clrMapOvr>
+    <a:masterClrMapping/>
+  </p:clrMapOvr>
+</p:sld>
+</file>
+
+<file path=ppt/slides/slide27.xml><?xml version="1.0" encoding="utf-8"?>
+<p:sld xmlns:a="http://schemas.openxmlformats.org/drawingml/2006/main" xmlns:r="http://schemas.openxmlformats.org/officeDocument/2006/relationships" xmlns:p="http://schemas.openxmlformats.org/presentationml/2006/main">
+  <p:cSld>
+    <p:spTree>
+      <p:nvGrpSpPr>
+        <p:cNvPr id="1" name=""/>
+        <p:cNvGrpSpPr/>
+        <p:nvPr/>
+      </p:nvGrpSpPr>
+      <p:grpSpPr>
+        <a:xfrm>
+          <a:off x="0" y="0"/>
+          <a:ext cx="0" cy="0"/>
+          <a:chOff x="0" y="0"/>
+          <a:chExt cx="0" cy="0"/>
+        </a:xfrm>
+      </p:grpSpPr>
+      <p:sp>
+        <p:nvSpPr>
+          <p:cNvPr id="2" name="Title 1"/>
+          <p:cNvSpPr>
+            <a:spLocks noGrp="1"/>
+          </p:cNvSpPr>
+          <p:nvPr>
+            <p:ph type="title"/>
+          </p:nvPr>
+        </p:nvSpPr>
+        <p:spPr/>
+        <p:txBody>
+          <a:bodyPr/>
+          <a:lstStyle/>
+          <a:p>
+            <a:r>
+              <a:t>Tempo de bloqueio dos envios por tamanho — SDumont</a:t>
+            </a:r>
+          </a:p>
+        </p:txBody>
+      </p:sp>
+      <p:sp>
+        <p:nvSpPr>
+          <p:cNvPr id="4" name="Text Placeholder 3"/>
+          <p:cNvSpPr>
+            <a:spLocks noGrp="1"/>
+          </p:cNvSpPr>
+          <p:nvPr>
+            <p:ph type="body" sz="quarter" idx="13"/>
+          </p:nvPr>
+        </p:nvSpPr>
+        <p:spPr/>
+        <p:txBody>
+          <a:bodyPr/>
+          <a:lstStyle/>
+          <a:p>
+            <a:r>
+              <a:rPr sz="1400"/>
+              <a:t>Capítulo 4 — Figura 4.10</a:t>
+            </a:r>
+          </a:p>
+        </p:txBody>
+      </p:sp>
+      <p:pic>
+        <p:nvPicPr>
+          <p:cNvPr id="5" name="Picture 4" descr="EnvioPorTamanho_SDumont.png"/>
+          <p:cNvPicPr>
+            <a:picLocks noChangeAspect="1"/>
+          </p:cNvPicPr>
+          <p:nvPr/>
+        </p:nvPicPr>
+        <p:blipFill>
+          <a:blip r:embed="rId3"/>
+          <a:stretch>
+            <a:fillRect/>
+          </a:stretch>
+        </p:blipFill>
+        <p:spPr>
+          <a:xfrm>
+            <a:off x="3009616" y="1371601"/>
+            <a:ext cx="6135809" cy="4924424"/>
+          </a:xfrm>
+          <a:prstGeom prst="rect">
+            <a:avLst/>
+          </a:prstGeom>
+        </p:spPr>
+      </p:pic>
+    </p:spTree>
   </p:cSld>
   <p:clrMapOvr>
     <a:masterClrMapping/>

</xml_diff>